<commit_message>
Cap nhat file bao cao
</commit_message>
<xml_diff>
--- a/Bao cao AppCafe.pptx
+++ b/Bao cao AppCafe.pptx
@@ -222,7 +222,7 @@
           <a:p>
             <a:fld id="{CCFD6714-BEF0-4B84-9835-BA2065B06EC0}" type="datetimeFigureOut">
               <a:rPr lang="vi-VN" smtClean="0"/>
-              <a:t>16/07/2026</a:t>
+              <a:t>17/07/2026</a:t>
             </a:fld>
             <a:endParaRPr lang="vi-VN"/>
           </a:p>
@@ -668,6 +668,13 @@
               <a:schemeClr val="lt1"/>
             </a:fontRef>
           </p:style>
+          <p:txBody>
+            <a:bodyPr/>
+            <a:lstStyle/>
+            <a:p>
+              <a:endParaRPr lang="en-US"/>
+            </a:p>
+          </p:txBody>
         </p:sp>
         <p:pic>
           <p:nvPicPr>
@@ -905,7 +912,7 @@
           <a:p>
             <a:fld id="{703F0899-9528-469E-9BBE-2D68CEF04D36}" type="datetime1">
               <a:rPr lang="vi-VN" smtClean="0"/>
-              <a:t>16/07/2026</a:t>
+              <a:t>17/07/2026</a:t>
             </a:fld>
             <a:endParaRPr lang="vi-VN"/>
           </a:p>
@@ -1229,7 +1236,7 @@
           <a:p>
             <a:fld id="{8E056C70-0CB9-4A9D-9A8F-A65F5171E703}" type="datetime1">
               <a:rPr lang="vi-VN" smtClean="0"/>
-              <a:t>16/07/2026</a:t>
+              <a:t>17/07/2026</a:t>
             </a:fld>
             <a:endParaRPr lang="vi-VN"/>
           </a:p>
@@ -1478,7 +1485,7 @@
           <a:p>
             <a:fld id="{8E056C70-0CB9-4A9D-9A8F-A65F5171E703}" type="datetime1">
               <a:rPr lang="vi-VN" smtClean="0"/>
-              <a:t>16/07/2026</a:t>
+              <a:t>17/07/2026</a:t>
             </a:fld>
             <a:endParaRPr lang="vi-VN"/>
           </a:p>
@@ -1818,7 +1825,7 @@
           <a:p>
             <a:fld id="{8E056C70-0CB9-4A9D-9A8F-A65F5171E703}" type="datetime1">
               <a:rPr lang="vi-VN" smtClean="0"/>
-              <a:t>16/07/2026</a:t>
+              <a:t>17/07/2026</a:t>
             </a:fld>
             <a:endParaRPr lang="vi-VN"/>
           </a:p>
@@ -2166,7 +2173,7 @@
           <a:p>
             <a:fld id="{8E056C70-0CB9-4A9D-9A8F-A65F5171E703}" type="datetime1">
               <a:rPr lang="vi-VN" smtClean="0"/>
-              <a:t>16/07/2026</a:t>
+              <a:t>17/07/2026</a:t>
             </a:fld>
             <a:endParaRPr lang="vi-VN"/>
           </a:p>
@@ -2541,7 +2548,7 @@
           <a:p>
             <a:fld id="{8E056C70-0CB9-4A9D-9A8F-A65F5171E703}" type="datetime1">
               <a:rPr lang="vi-VN" smtClean="0"/>
-              <a:t>16/07/2026</a:t>
+              <a:t>17/07/2026</a:t>
             </a:fld>
             <a:endParaRPr lang="vi-VN"/>
           </a:p>
@@ -3012,7 +3019,7 @@
           <a:p>
             <a:fld id="{8E056C70-0CB9-4A9D-9A8F-A65F5171E703}" type="datetime1">
               <a:rPr lang="vi-VN" smtClean="0"/>
-              <a:t>16/07/2026</a:t>
+              <a:t>17/07/2026</a:t>
             </a:fld>
             <a:endParaRPr lang="vi-VN"/>
           </a:p>
@@ -3218,7 +3225,7 @@
           <a:p>
             <a:fld id="{2EC49E89-C61F-4DF0-A1BB-4BDC6A0E3388}" type="datetime1">
               <a:rPr lang="vi-VN" smtClean="0"/>
-              <a:t>16/07/2026</a:t>
+              <a:t>17/07/2026</a:t>
             </a:fld>
             <a:endParaRPr lang="vi-VN"/>
           </a:p>
@@ -3429,7 +3436,7 @@
           <a:p>
             <a:fld id="{B19C4B38-BFCE-46D5-A0E5-B1F664C0A5C1}" type="datetime1">
               <a:rPr lang="vi-VN" smtClean="0"/>
-              <a:t>16/07/2026</a:t>
+              <a:t>17/07/2026</a:t>
             </a:fld>
             <a:endParaRPr lang="vi-VN"/>
           </a:p>
@@ -3661,7 +3668,7 @@
           <a:p>
             <a:fld id="{902DE2E4-5C89-45BE-93FC-CFD48110491D}" type="datetime1">
               <a:rPr lang="vi-VN" smtClean="0"/>
-              <a:t>16/07/2026</a:t>
+              <a:t>17/07/2026</a:t>
             </a:fld>
             <a:endParaRPr lang="vi-VN"/>
           </a:p>
@@ -3909,7 +3916,7 @@
           <a:p>
             <a:fld id="{C8EBFE73-F336-4262-8B3B-60000544237C}" type="datetime1">
               <a:rPr lang="vi-VN" smtClean="0"/>
-              <a:t>16/07/2026</a:t>
+              <a:t>17/07/2026</a:t>
             </a:fld>
             <a:endParaRPr lang="vi-VN"/>
           </a:p>
@@ -4207,7 +4214,7 @@
           <a:p>
             <a:fld id="{D873CB7E-FBC1-4898-921B-CA7099ECCD24}" type="datetime1">
               <a:rPr lang="vi-VN" smtClean="0"/>
-              <a:t>16/07/2026</a:t>
+              <a:t>17/07/2026</a:t>
             </a:fld>
             <a:endParaRPr lang="vi-VN"/>
           </a:p>
@@ -4601,7 +4608,7 @@
           <a:p>
             <a:fld id="{C7549885-1DDE-491E-80FA-9454E70A916B}" type="datetime1">
               <a:rPr lang="vi-VN" smtClean="0"/>
-              <a:t>16/07/2026</a:t>
+              <a:t>17/07/2026</a:t>
             </a:fld>
             <a:endParaRPr lang="vi-VN"/>
           </a:p>
@@ -4750,7 +4757,7 @@
           <a:p>
             <a:fld id="{AE04768D-2B32-4874-9EA2-F91ED5E4D91C}" type="datetime1">
               <a:rPr lang="vi-VN" smtClean="0"/>
-              <a:t>16/07/2026</a:t>
+              <a:t>17/07/2026</a:t>
             </a:fld>
             <a:endParaRPr lang="vi-VN"/>
           </a:p>
@@ -4876,7 +4883,7 @@
           <a:p>
             <a:fld id="{15D76658-C092-47DC-8AE5-EDAD243FFD08}" type="datetime1">
               <a:rPr lang="vi-VN" smtClean="0"/>
-              <a:t>16/07/2026</a:t>
+              <a:t>17/07/2026</a:t>
             </a:fld>
             <a:endParaRPr lang="vi-VN"/>
           </a:p>
@@ -5131,7 +5138,7 @@
           <a:p>
             <a:fld id="{7F966A3C-4EA8-4F4D-8541-7E7080DF1B30}" type="datetime1">
               <a:rPr lang="vi-VN" smtClean="0"/>
-              <a:t>16/07/2026</a:t>
+              <a:t>17/07/2026</a:t>
             </a:fld>
             <a:endParaRPr lang="vi-VN"/>
           </a:p>
@@ -5446,7 +5453,7 @@
           <a:p>
             <a:fld id="{48E68AFB-A54D-4DD5-8E7A-EF7D2A0C1D5A}" type="datetime1">
               <a:rPr lang="vi-VN" smtClean="0"/>
-              <a:t>16/07/2026</a:t>
+              <a:t>17/07/2026</a:t>
             </a:fld>
             <a:endParaRPr lang="vi-VN"/>
           </a:p>
@@ -5606,6 +5613,13 @@
               <a:schemeClr val="lt1"/>
             </a:fontRef>
           </p:style>
+          <p:txBody>
+            <a:bodyPr/>
+            <a:lstStyle/>
+            <a:p>
+              <a:endParaRPr lang="en-US"/>
+            </a:p>
+          </p:txBody>
         </p:sp>
         <p:pic>
           <p:nvPicPr>
@@ -5797,7 +5811,7 @@
           <a:p>
             <a:fld id="{8E056C70-0CB9-4A9D-9A8F-A65F5171E703}" type="datetime1">
               <a:rPr lang="vi-VN" smtClean="0"/>
-              <a:t>16/07/2026</a:t>
+              <a:t>17/07/2026</a:t>
             </a:fld>
             <a:endParaRPr lang="vi-VN"/>
           </a:p>
@@ -6547,6 +6561,10 @@
           <a:p>
             <a:pPr algn="l"/>
             <a:r>
+              <a:rPr lang="en-US" b="1" dirty="0"/>
+              <a:t>2411110079</a:t>
+            </a:r>
+            <a:r>
               <a:rPr lang="en-US" b="1" dirty="0">
                 <a:solidFill>
                   <a:schemeClr val="tx1"/>
@@ -6554,7 +6572,7 @@
                 <a:latin typeface="Times New Roman" panose="02020603050405020304" pitchFamily="18" charset="0"/>
                 <a:cs typeface="Times New Roman" panose="02020603050405020304" pitchFamily="18" charset="0"/>
               </a:rPr>
-              <a:t>24111100 – Nguyễn</a:t>
+              <a:t> – Nguyễn</a:t>
             </a:r>
             <a:r>
               <a:rPr lang="vi-VN" b="1" dirty="0">

</xml_diff>